<commit_message>
Eliminate slide white space: enrich pillars, enterprise architecture, and clinical safety workflow
</commit_message>
<xml_diff>
--- a/deck/Swasth_Presentation.pptx
+++ b/deck/Swasth_Presentation.pptx
@@ -4061,8 +4061,8 @@
         </p:nvSpPr>
         <p:spPr>
           <a:xfrm>
-            <a:off x="731520" y="1828800"/>
-            <a:ext cx="3383280" cy="2011680"/>
+            <a:off x="731520" y="1737360"/>
+            <a:ext cx="3429000" cy="2240280"/>
           </a:xfrm>
           <a:prstGeom prst="roundRect">
             <a:avLst/>
@@ -4091,33 +4091,93 @@
           </a:fontRef>
         </p:style>
         <p:txBody>
-          <a:bodyPr rtlCol="0" anchor="ctr" wrap="square" tIns="164592" lIns="182880" rIns="182880"/>
+          <a:bodyPr rtlCol="0" anchor="ctr" wrap="square" tIns="109728" lIns="137160" rIns="137160" bIns="91440"/>
           <a:lstStyle/>
           <a:p>
             <a:pPr algn="ctr">
-              <a:defRPr sz="1400" b="1">
+              <a:defRPr sz="950" b="1">
+                <a:solidFill>
+                  <a:srgbClr val="E93B67"/>
+                </a:solidFill>
+              </a:defRPr>
+            </a:pPr>
+            <a:r>
+              <a:t>01. CARE JOURNEY COMPANION</a:t>
+            </a:r>
+          </a:p>
+          <a:p>
+            <a:pPr>
+              <a:spcBef>
+                <a:spcPts val="100"/>
+              </a:spcBef>
+              <a:defRPr sz="1300" b="1">
                 <a:solidFill>
                   <a:srgbClr val="0F172A"/>
                 </a:solidFill>
               </a:defRPr>
             </a:pPr>
             <a:r>
-              <a:t>01. Care Journey Companion</a:t>
-            </a:r>
-          </a:p>
-          <a:p>
-            <a:pPr>
-              <a:spcBef>
-                <a:spcPts val="600"/>
-              </a:spcBef>
-              <a:defRPr sz="1100">
-                <a:solidFill>
-                  <a:srgbClr val="64748B"/>
-                </a:solidFill>
-              </a:defRPr>
-            </a:pPr>
-            <a:r>
-              <a:t>Stage-aware guidance tailored across planning, trimester weeks, and 0-24 month infancy. Clear guidance on what to prepare and when to visit.</a:t>
+              <a:t>Stage-Aware Guidance</a:t>
+            </a:r>
+          </a:p>
+          <a:p>
+            <a:pPr>
+              <a:spcBef>
+                <a:spcPts val="200"/>
+              </a:spcBef>
+              <a:defRPr sz="1000">
+                <a:solidFill>
+                  <a:srgbClr val="334155"/>
+                </a:solidFill>
+              </a:defRPr>
+            </a:pPr>
+            <a:r>
+              <a:t>✓ Trimester checklists &amp; delivery bag planner</a:t>
+            </a:r>
+          </a:p>
+          <a:p>
+            <a:pPr>
+              <a:spcBef>
+                <a:spcPts val="200"/>
+              </a:spcBef>
+              <a:defRPr sz="1000">
+                <a:solidFill>
+                  <a:srgbClr val="334155"/>
+                </a:solidFill>
+              </a:defRPr>
+            </a:pPr>
+            <a:r>
+              <a:t>✓ Weekly baby development &amp; fruit-size analogies</a:t>
+            </a:r>
+          </a:p>
+          <a:p>
+            <a:pPr>
+              <a:spcBef>
+                <a:spcPts val="200"/>
+              </a:spcBef>
+              <a:defRPr sz="1000">
+                <a:solidFill>
+                  <a:srgbClr val="334155"/>
+                </a:solidFill>
+              </a:defRPr>
+            </a:pPr>
+            <a:r>
+              <a:t>✓ 42-day postpartum lochia recovery tracking</a:t>
+            </a:r>
+          </a:p>
+          <a:p>
+            <a:pPr>
+              <a:spcBef>
+                <a:spcPts val="400"/>
+              </a:spcBef>
+              <a:defRPr sz="950" b="1">
+                <a:solidFill>
+                  <a:srgbClr val="E93B67"/>
+                </a:solidFill>
+              </a:defRPr>
+            </a:pPr>
+            <a:r>
+              <a:t>📊 Target: 95% Milestone Awareness</a:t>
             </a:r>
           </a:p>
         </p:txBody>
@@ -4130,8 +4190,8 @@
         </p:nvSpPr>
         <p:spPr>
           <a:xfrm>
-            <a:off x="4389120" y="1828800"/>
-            <a:ext cx="3383280" cy="2011680"/>
+            <a:off x="4389120" y="1737360"/>
+            <a:ext cx="3429000" cy="2240280"/>
           </a:xfrm>
           <a:prstGeom prst="roundRect">
             <a:avLst/>
@@ -4160,33 +4220,93 @@
           </a:fontRef>
         </p:style>
         <p:txBody>
-          <a:bodyPr rtlCol="0" anchor="ctr" wrap="square" tIns="164592" lIns="182880" rIns="182880"/>
+          <a:bodyPr rtlCol="0" anchor="ctr" wrap="square" tIns="109728" lIns="137160" rIns="137160" bIns="91440"/>
           <a:lstStyle/>
           <a:p>
             <a:pPr algn="ctr">
-              <a:defRPr sz="1400" b="1">
+              <a:defRPr sz="950" b="1">
+                <a:solidFill>
+                  <a:srgbClr val="E93B67"/>
+                </a:solidFill>
+              </a:defRPr>
+            </a:pPr>
+            <a:r>
+              <a:t>02. LONG-TERM CARE ENGAGEMENT</a:t>
+            </a:r>
+          </a:p>
+          <a:p>
+            <a:pPr>
+              <a:spcBef>
+                <a:spcPts val="100"/>
+              </a:spcBef>
+              <a:defRPr sz="1300" b="1">
                 <a:solidFill>
                   <a:srgbClr val="0F172A"/>
                 </a:solidFill>
               </a:defRPr>
             </a:pPr>
             <a:r>
-              <a:t>02. Long-Term Engagement</a:t>
-            </a:r>
-          </a:p>
-          <a:p>
-            <a:pPr>
-              <a:spcBef>
-                <a:spcPts val="600"/>
-              </a:spcBef>
-              <a:defRPr sz="1100">
-                <a:solidFill>
-                  <a:srgbClr val="64748B"/>
-                </a:solidFill>
-              </a:defRPr>
-            </a:pPr>
-            <a:r>
-              <a:t>Sustained adherence over months &amp; years via Garbh Sanskar daily micro-habits, birth club peer communities, and milestone streaks.</a:t>
+              <a:t>Sustained Multi-Year Adherence</a:t>
+            </a:r>
+          </a:p>
+          <a:p>
+            <a:pPr>
+              <a:spcBef>
+                <a:spcPts val="200"/>
+              </a:spcBef>
+              <a:defRPr sz="1000">
+                <a:solidFill>
+                  <a:srgbClr val="334155"/>
+                </a:solidFill>
+              </a:defRPr>
+            </a:pPr>
+            <a:r>
+              <a:t>✓ Daily 4Q Garbh Sanskar routines (IQ, EQ, PQ, SQ)</a:t>
+            </a:r>
+          </a:p>
+          <a:p>
+            <a:pPr>
+              <a:spcBef>
+                <a:spcPts val="200"/>
+              </a:spcBef>
+              <a:defRPr sz="1000">
+                <a:solidFill>
+                  <a:srgbClr val="334155"/>
+                </a:solidFill>
+              </a:defRPr>
+            </a:pPr>
+            <a:r>
+              <a:t>✓ Milestone streak badges &amp; celebration rewards</a:t>
+            </a:r>
+          </a:p>
+          <a:p>
+            <a:pPr>
+              <a:spcBef>
+                <a:spcPts val="200"/>
+              </a:spcBef>
+              <a:defRPr sz="1000">
+                <a:solidFill>
+                  <a:srgbClr val="334155"/>
+                </a:solidFill>
+              </a:defRPr>
+            </a:pPr>
+            <a:r>
+              <a:t>✓ Hyperlocal Birth Clubs for peer empathy circles</a:t>
+            </a:r>
+          </a:p>
+          <a:p>
+            <a:pPr>
+              <a:spcBef>
+                <a:spcPts val="400"/>
+              </a:spcBef>
+              <a:defRPr sz="950" b="1">
+                <a:solidFill>
+                  <a:srgbClr val="E93B67"/>
+                </a:solidFill>
+              </a:defRPr>
+            </a:pPr>
+            <a:r>
+              <a:t>📊 Target: &gt;80% 90-Day Retention</a:t>
             </a:r>
           </a:p>
         </p:txBody>
@@ -4199,8 +4319,8 @@
         </p:nvSpPr>
         <p:spPr>
           <a:xfrm>
-            <a:off x="8046720" y="1828800"/>
-            <a:ext cx="3383280" cy="2011680"/>
+            <a:off x="8046720" y="1737360"/>
+            <a:ext cx="3429000" cy="2240280"/>
           </a:xfrm>
           <a:prstGeom prst="roundRect">
             <a:avLst/>
@@ -4229,33 +4349,93 @@
           </a:fontRef>
         </p:style>
         <p:txBody>
-          <a:bodyPr rtlCol="0" anchor="ctr" wrap="square" tIns="164592" lIns="182880" rIns="182880"/>
+          <a:bodyPr rtlCol="0" anchor="ctr" wrap="square" tIns="109728" lIns="137160" rIns="137160" bIns="91440"/>
           <a:lstStyle/>
           <a:p>
             <a:pPr algn="ctr">
-              <a:defRPr sz="1400" b="1">
+              <a:defRPr sz="950" b="1">
+                <a:solidFill>
+                  <a:srgbClr val="E93B67"/>
+                </a:solidFill>
+              </a:defRPr>
+            </a:pPr>
+            <a:r>
+              <a:t>03. FAMILY &amp; CAREGIVER SUPPORT</a:t>
+            </a:r>
+          </a:p>
+          <a:p>
+            <a:pPr>
+              <a:spcBef>
+                <a:spcPts val="100"/>
+              </a:spcBef>
+              <a:defRPr sz="1300" b="1">
                 <a:solidFill>
                   <a:srgbClr val="0F172A"/>
                 </a:solidFill>
               </a:defRPr>
             </a:pPr>
             <a:r>
-              <a:t>03. Family &amp; Caregiver Support</a:t>
-            </a:r>
-          </a:p>
-          <a:p>
-            <a:pPr>
-              <a:spcBef>
-                <a:spcPts val="600"/>
-              </a:spcBef>
-              <a:defRPr sz="1100">
-                <a:solidFill>
-                  <a:srgbClr val="64748B"/>
-                </a:solidFill>
-              </a:defRPr>
-            </a:pPr>
-            <a:r>
-              <a:t>Caregiver synchronization tools empowering husbands and elders with localized voice/WhatsApp alerts, reducing stress on the mother.</a:t>
+              <a:t>Caregiver Synchronization</a:t>
+            </a:r>
+          </a:p>
+          <a:p>
+            <a:pPr>
+              <a:spcBef>
+                <a:spcPts val="200"/>
+              </a:spcBef>
+              <a:defRPr sz="1000">
+                <a:solidFill>
+                  <a:srgbClr val="334155"/>
+                </a:solidFill>
+              </a:defRPr>
+            </a:pPr>
+            <a:r>
+              <a:t>✓ Husband prep checklists &amp; appointment sync</a:t>
+            </a:r>
+          </a:p>
+          <a:p>
+            <a:pPr>
+              <a:spcBef>
+                <a:spcPts val="200"/>
+              </a:spcBef>
+              <a:defRPr sz="1000">
+                <a:solidFill>
+                  <a:srgbClr val="334155"/>
+                </a:solidFill>
+              </a:defRPr>
+            </a:pPr>
+            <a:r>
+              <a:t>✓ Vernacular voice nudges for family elders</a:t>
+            </a:r>
+          </a:p>
+          <a:p>
+            <a:pPr>
+              <a:spcBef>
+                <a:spcPts val="200"/>
+              </a:spcBef>
+              <a:defRPr sz="1000">
+                <a:solidFill>
+                  <a:srgbClr val="334155"/>
+                </a:solidFill>
+              </a:defRPr>
+            </a:pPr>
+            <a:r>
+              <a:t>✓ Shared emergency transport &amp; blood donor plans</a:t>
+            </a:r>
+          </a:p>
+          <a:p>
+            <a:pPr>
+              <a:spcBef>
+                <a:spcPts val="400"/>
+              </a:spcBef>
+              <a:defRPr sz="950" b="1">
+                <a:solidFill>
+                  <a:srgbClr val="E93B67"/>
+                </a:solidFill>
+              </a:defRPr>
+            </a:pPr>
+            <a:r>
+              <a:t>📊 Target: 3x Caregiver Participation</a:t>
             </a:r>
           </a:p>
         </p:txBody>
@@ -4269,7 +4449,7 @@
         <p:spPr>
           <a:xfrm>
             <a:off x="731520" y="4114800"/>
-            <a:ext cx="3383280" cy="2011680"/>
+            <a:ext cx="3429000" cy="2240280"/>
           </a:xfrm>
           <a:prstGeom prst="roundRect">
             <a:avLst/>
@@ -4298,33 +4478,93 @@
           </a:fontRef>
         </p:style>
         <p:txBody>
-          <a:bodyPr rtlCol="0" anchor="ctr" wrap="square" tIns="164592" lIns="182880" rIns="182880"/>
+          <a:bodyPr rtlCol="0" anchor="ctr" wrap="square" tIns="109728" lIns="137160" rIns="137160" bIns="91440"/>
           <a:lstStyle/>
           <a:p>
             <a:pPr algn="ctr">
-              <a:defRPr sz="1400" b="1">
+              <a:defRPr sz="950" b="1">
+                <a:solidFill>
+                  <a:srgbClr val="E93B67"/>
+                </a:solidFill>
+              </a:defRPr>
+            </a:pPr>
+            <a:r>
+              <a:t>04. HEALTHCARE NAVIGATION</a:t>
+            </a:r>
+          </a:p>
+          <a:p>
+            <a:pPr>
+              <a:spcBef>
+                <a:spcPts val="100"/>
+              </a:spcBef>
+              <a:defRPr sz="1300" b="1">
                 <a:solidFill>
                   <a:srgbClr val="0F172A"/>
                 </a:solidFill>
               </a:defRPr>
             </a:pPr>
             <a:r>
-              <a:t>04. Healthcare Navigation</a:t>
-            </a:r>
-          </a:p>
-          <a:p>
-            <a:pPr>
-              <a:spcBef>
-                <a:spcPts val="600"/>
-              </a:spcBef>
-              <a:defRPr sz="1100">
-                <a:solidFill>
-                  <a:srgbClr val="64748B"/>
-                </a:solidFill>
-              </a:defRPr>
-            </a:pPr>
-            <a:r>
-              <a:t>Clear operational next steps across clinic token counters, lab tests, ultrasound schedules, and PHC-to-District referral handoffs.</a:t>
+              <a:t>Clinic &amp; Facility Guidance</a:t>
+            </a:r>
+          </a:p>
+          <a:p>
+            <a:pPr>
+              <a:spcBef>
+                <a:spcPts val="200"/>
+              </a:spcBef>
+              <a:defRPr sz="1000">
+                <a:solidFill>
+                  <a:srgbClr val="334155"/>
+                </a:solidFill>
+              </a:defRPr>
+            </a:pPr>
+            <a:r>
+              <a:t>✓ Ultrasound scan window alerts &amp; fasting steps</a:t>
+            </a:r>
+          </a:p>
+          <a:p>
+            <a:pPr>
+              <a:spcBef>
+                <a:spcPts val="200"/>
+              </a:spcBef>
+              <a:defRPr sz="1000">
+                <a:solidFill>
+                  <a:srgbClr val="334155"/>
+                </a:solidFill>
+              </a:defRPr>
+            </a:pPr>
+            <a:r>
+              <a:t>✓ PHC-to-District referral handoff documentation</a:t>
+            </a:r>
+          </a:p>
+          <a:p>
+            <a:pPr>
+              <a:spcBef>
+                <a:spcPts val="200"/>
+              </a:spcBef>
+              <a:defRPr sz="1000">
+                <a:solidFill>
+                  <a:srgbClr val="334155"/>
+                </a:solidFill>
+              </a:defRPr>
+            </a:pPr>
+            <a:r>
+              <a:t>✓ Pre-filled check-in questions for doctor visits</a:t>
+            </a:r>
+          </a:p>
+          <a:p>
+            <a:pPr>
+              <a:spcBef>
+                <a:spcPts val="400"/>
+              </a:spcBef>
+              <a:defRPr sz="950" b="1">
+                <a:solidFill>
+                  <a:srgbClr val="E93B67"/>
+                </a:solidFill>
+              </a:defRPr>
+            </a:pPr>
+            <a:r>
+              <a:t>📊 Target: 40% Shorter Clinic Wait Time</a:t>
             </a:r>
           </a:p>
         </p:txBody>
@@ -4338,7 +4578,7 @@
         <p:spPr>
           <a:xfrm>
             <a:off x="4389120" y="4114800"/>
-            <a:ext cx="3383280" cy="2011680"/>
+            <a:ext cx="3429000" cy="2240280"/>
           </a:xfrm>
           <a:prstGeom prst="roundRect">
             <a:avLst/>
@@ -4367,33 +4607,93 @@
           </a:fontRef>
         </p:style>
         <p:txBody>
-          <a:bodyPr rtlCol="0" anchor="ctr" wrap="square" tIns="164592" lIns="182880" rIns="182880"/>
+          <a:bodyPr rtlCol="0" anchor="ctr" wrap="square" tIns="109728" lIns="137160" rIns="137160" bIns="91440"/>
           <a:lstStyle/>
           <a:p>
             <a:pPr algn="ctr">
-              <a:defRPr sz="1400" b="1">
+              <a:defRPr sz="950" b="1">
+                <a:solidFill>
+                  <a:srgbClr val="E93B67"/>
+                </a:solidFill>
+              </a:defRPr>
+            </a:pPr>
+            <a:r>
+              <a:t>05. FINANCIAL &amp; ADMIN SUPPORT</a:t>
+            </a:r>
+          </a:p>
+          <a:p>
+            <a:pPr>
+              <a:spcBef>
+                <a:spcPts val="100"/>
+              </a:spcBef>
+              <a:defRPr sz="1300" b="1">
                 <a:solidFill>
                   <a:srgbClr val="0F172A"/>
                 </a:solidFill>
               </a:defRPr>
             </a:pPr>
             <a:r>
-              <a:t>05. Financial &amp; Admin Support</a:t>
-            </a:r>
-          </a:p>
-          <a:p>
-            <a:pPr>
-              <a:spcBef>
-                <a:spcPts val="600"/>
-              </a:spcBef>
-              <a:defRPr sz="1100">
-                <a:solidFill>
-                  <a:srgbClr val="64748B"/>
-                </a:solidFill>
-              </a:defRPr>
-            </a:pPr>
-            <a:r>
-              <a:t>Simplifies maternity schemes (PMMVY, JSY, JSSK) and hospital documentation so financial paperwork never delays care.</a:t>
+              <a:t>Maternity Scheme Navigator</a:t>
+            </a:r>
+          </a:p>
+          <a:p>
+            <a:pPr>
+              <a:spcBef>
+                <a:spcPts val="200"/>
+              </a:spcBef>
+              <a:defRPr sz="1000">
+                <a:solidFill>
+                  <a:srgbClr val="334155"/>
+                </a:solidFill>
+              </a:defRPr>
+            </a:pPr>
+            <a:r>
+              <a:t>✓ PMMVY (₹5,000 grant) document tracker</a:t>
+            </a:r>
+          </a:p>
+          <a:p>
+            <a:pPr>
+              <a:spcBef>
+                <a:spcPts val="200"/>
+              </a:spcBef>
+              <a:defRPr sz="1000">
+                <a:solidFill>
+                  <a:srgbClr val="334155"/>
+                </a:solidFill>
+              </a:defRPr>
+            </a:pPr>
+            <a:r>
+              <a:t>✓ JSY &amp; JSSK cash transfer entitlement guides</a:t>
+            </a:r>
+          </a:p>
+          <a:p>
+            <a:pPr>
+              <a:spcBef>
+                <a:spcPts val="200"/>
+              </a:spcBef>
+              <a:defRPr sz="1000">
+                <a:solidFill>
+                  <a:srgbClr val="334155"/>
+                </a:solidFill>
+              </a:defRPr>
+            </a:pPr>
+            <a:r>
+              <a:t>✓ Direct digital integration with ABHA ID</a:t>
+            </a:r>
+          </a:p>
+          <a:p>
+            <a:pPr>
+              <a:spcBef>
+                <a:spcPts val="400"/>
+              </a:spcBef>
+              <a:defRPr sz="950" b="1">
+                <a:solidFill>
+                  <a:srgbClr val="E93B67"/>
+                </a:solidFill>
+              </a:defRPr>
+            </a:pPr>
+            <a:r>
+              <a:t>📊 Target: 100% Scheme Realization</a:t>
             </a:r>
           </a:p>
         </p:txBody>
@@ -4407,7 +4707,7 @@
         <p:spPr>
           <a:xfrm>
             <a:off x="8046720" y="4114800"/>
-            <a:ext cx="3383280" cy="2011680"/>
+            <a:ext cx="3429000" cy="2240280"/>
           </a:xfrm>
           <a:prstGeom prst="roundRect">
             <a:avLst/>
@@ -4436,33 +4736,93 @@
           </a:fontRef>
         </p:style>
         <p:txBody>
-          <a:bodyPr rtlCol="0" anchor="ctr" wrap="square" tIns="164592" lIns="182880" rIns="182880"/>
+          <a:bodyPr rtlCol="0" anchor="ctr" wrap="square" tIns="109728" lIns="137160" rIns="137160" bIns="91440"/>
           <a:lstStyle/>
           <a:p>
             <a:pPr algn="ctr">
-              <a:defRPr sz="1400" b="1">
+              <a:defRPr sz="950" b="1">
+                <a:solidFill>
+                  <a:srgbClr val="E93B67"/>
+                </a:solidFill>
+              </a:defRPr>
+            </a:pPr>
+            <a:r>
+              <a:t>06. PATIENT JOURNEY PROGRESS</a:t>
+            </a:r>
+          </a:p>
+          <a:p>
+            <a:pPr>
+              <a:spcBef>
+                <a:spcPts val="100"/>
+              </a:spcBef>
+              <a:defRPr sz="1300" b="1">
                 <a:solidFill>
                   <a:srgbClr val="0F172A"/>
                 </a:solidFill>
               </a:defRPr>
             </a:pPr>
             <a:r>
-              <a:t>06. Longitudinal Journey Progress</a:t>
-            </a:r>
-          </a:p>
-          <a:p>
-            <a:pPr>
-              <a:spcBef>
-                <a:spcPts val="600"/>
-              </a:spcBef>
-              <a:defRPr sz="1100">
-                <a:solidFill>
-                  <a:srgbClr val="64748B"/>
-                </a:solidFill>
-              </a:defRPr>
-            </a:pPr>
-            <a:r>
-              <a:t>A simple, visual timeline of completed, pending, and upcoming clinical and developmental milestones at a single glance.</a:t>
+              <a:t>Longitudinal Milestone View</a:t>
+            </a:r>
+          </a:p>
+          <a:p>
+            <a:pPr>
+              <a:spcBef>
+                <a:spcPts val="200"/>
+              </a:spcBef>
+              <a:defRPr sz="1000">
+                <a:solidFill>
+                  <a:srgbClr val="334155"/>
+                </a:solidFill>
+              </a:defRPr>
+            </a:pPr>
+            <a:r>
+              <a:t>✓ Digital MCP card sync with cloud backup</a:t>
+            </a:r>
+          </a:p>
+          <a:p>
+            <a:pPr>
+              <a:spcBef>
+                <a:spcPts val="200"/>
+              </a:spcBef>
+              <a:defRPr sz="1000">
+                <a:solidFill>
+                  <a:srgbClr val="334155"/>
+                </a:solidFill>
+              </a:defRPr>
+            </a:pPr>
+            <a:r>
+              <a:t>✓ Visual tracking of 7 infant vaccine cohorts</a:t>
+            </a:r>
+          </a:p>
+          <a:p>
+            <a:pPr>
+              <a:spcBef>
+                <a:spcPts val="200"/>
+              </a:spcBef>
+              <a:defRPr sz="1000">
+                <a:solidFill>
+                  <a:srgbClr val="334155"/>
+                </a:solidFill>
+              </a:defRPr>
+            </a:pPr>
+            <a:r>
+              <a:t>✓ Verified doctor visit summary archive</a:t>
+            </a:r>
+          </a:p>
+          <a:p>
+            <a:pPr>
+              <a:spcBef>
+                <a:spcPts val="400"/>
+              </a:spcBef>
+              <a:defRPr sz="950" b="1">
+                <a:solidFill>
+                  <a:srgbClr val="E93B67"/>
+                </a:solidFill>
+              </a:defRPr>
+            </a:pPr>
+            <a:r>
+              <a:t>📊 Target: Zero Lost Health Records</a:t>
             </a:r>
           </a:p>
         </p:txBody>
@@ -4874,8 +5234,8 @@
         </p:nvSpPr>
         <p:spPr>
           <a:xfrm>
-            <a:off x="731520" y="1920240"/>
-            <a:ext cx="2011680" cy="4206240"/>
+            <a:off x="731520" y="1737360"/>
+            <a:ext cx="2057400" cy="4663440"/>
           </a:xfrm>
           <a:prstGeom prst="roundRect">
             <a:avLst/>
@@ -4904,45 +5264,108 @@
           </a:fontRef>
         </p:style>
         <p:txBody>
-          <a:bodyPr rtlCol="0" anchor="ctr" wrap="square" tIns="182880" lIns="137160" rIns="137160"/>
+          <a:bodyPr rtlCol="0" anchor="ctr" wrap="square" tIns="137160" lIns="137160" rIns="137160" bIns="91440"/>
           <a:lstStyle/>
           <a:p>
             <a:pPr algn="ctr">
-              <a:defRPr sz="1500" b="1">
+              <a:defRPr sz="950" b="1">
                 <a:solidFill>
                   <a:srgbClr val="E93B67"/>
                 </a:solidFill>
               </a:defRPr>
             </a:pPr>
             <a:r>
-              <a:t>Client Layer</a:t>
-            </a:r>
-          </a:p>
-          <a:p>
-            <a:pPr>
-              <a:spcBef>
-                <a:spcPts val="1200"/>
-              </a:spcBef>
-              <a:defRPr sz="1100">
+              <a:t>CLIENT LAYER</a:t>
+            </a:r>
+          </a:p>
+          <a:p>
+            <a:pPr>
+              <a:spcBef>
+                <a:spcPts val="100"/>
+              </a:spcBef>
+              <a:defRPr sz="1400" b="1">
                 <a:solidFill>
                   <a:srgbClr val="0F172A"/>
                 </a:solidFill>
               </a:defRPr>
             </a:pPr>
             <a:r>
-              <a:t>Flutter Mobile App</a:t>
-            </a:r>
-            <a:br/>
-            <a:r>
-              <a:t>(iOS &amp; Android native 60 FPS)</a:t>
-            </a:r>
-            <a:br/>
-            <a:r>
-              <a:t>+ React/TypeScript Web backup</a:t>
-            </a:r>
-            <a:br/>
-            <a:r>
-              <a:t>Encrypted local offline store.</a:t>
+              <a:t>Flutter &amp; Web</a:t>
+            </a:r>
+          </a:p>
+          <a:p>
+            <a:pPr>
+              <a:spcBef>
+                <a:spcPts val="600"/>
+              </a:spcBef>
+              <a:defRPr sz="1000">
+                <a:solidFill>
+                  <a:srgbClr val="334155"/>
+                </a:solidFill>
+              </a:defRPr>
+            </a:pPr>
+            <a:r>
+              <a:t>• Flutter 3.x native (60–120 FPS)</a:t>
+            </a:r>
+          </a:p>
+          <a:p>
+            <a:pPr>
+              <a:spcBef>
+                <a:spcPts val="600"/>
+              </a:spcBef>
+              <a:defRPr sz="1000">
+                <a:solidFill>
+                  <a:srgbClr val="334155"/>
+                </a:solidFill>
+              </a:defRPr>
+            </a:pPr>
+            <a:r>
+              <a:t>• Hive local DB for 24/7 offline cache</a:t>
+            </a:r>
+          </a:p>
+          <a:p>
+            <a:pPr>
+              <a:spcBef>
+                <a:spcPts val="600"/>
+              </a:spcBef>
+              <a:defRPr sz="1000">
+                <a:solidFill>
+                  <a:srgbClr val="334155"/>
+                </a:solidFill>
+              </a:defRPr>
+            </a:pPr>
+            <a:r>
+              <a:t>• Lightweight React clinic backup portal</a:t>
+            </a:r>
+          </a:p>
+          <a:p>
+            <a:pPr>
+              <a:spcBef>
+                <a:spcPts val="600"/>
+              </a:spcBef>
+              <a:defRPr sz="1000">
+                <a:solidFill>
+                  <a:srgbClr val="334155"/>
+                </a:solidFill>
+              </a:defRPr>
+            </a:pPr>
+            <a:r>
+              <a:t>• &lt;18 MB APK size for rural devices</a:t>
+            </a:r>
+          </a:p>
+          <a:p>
+            <a:pPr>
+              <a:spcBef>
+                <a:spcPts val="1400"/>
+              </a:spcBef>
+              <a:defRPr sz="950" b="1">
+                <a:solidFill>
+                  <a:srgbClr val="E93B67"/>
+                </a:solidFill>
+              </a:defRPr>
+            </a:pPr>
+            <a:r>
+              <a:t>⚡ &lt;50ms UI Latency</a:t>
             </a:r>
           </a:p>
         </p:txBody>
@@ -4955,8 +5378,8 @@
         </p:nvSpPr>
         <p:spPr>
           <a:xfrm>
-            <a:off x="2926080" y="1920240"/>
-            <a:ext cx="2011680" cy="4206240"/>
+            <a:off x="2926080" y="1737360"/>
+            <a:ext cx="2057400" cy="4663440"/>
           </a:xfrm>
           <a:prstGeom prst="roundRect">
             <a:avLst/>
@@ -4985,37 +5408,108 @@
           </a:fontRef>
         </p:style>
         <p:txBody>
-          <a:bodyPr rtlCol="0" anchor="ctr" wrap="square" tIns="182880" lIns="137160" rIns="137160"/>
+          <a:bodyPr rtlCol="0" anchor="ctr" wrap="square" tIns="137160" lIns="137160" rIns="137160" bIns="91440"/>
           <a:lstStyle/>
           <a:p>
             <a:pPr algn="ctr">
-              <a:defRPr sz="1500" b="1">
+              <a:defRPr sz="950" b="1">
                 <a:solidFill>
                   <a:srgbClr val="4A6FA5"/>
                 </a:solidFill>
               </a:defRPr>
             </a:pPr>
             <a:r>
-              <a:t>Single Unified API</a:t>
-            </a:r>
-          </a:p>
-          <a:p>
-            <a:pPr>
-              <a:spcBef>
-                <a:spcPts val="1200"/>
-              </a:spcBef>
-              <a:defRPr sz="1100">
+              <a:t>UNIFIED BACKEND</a:t>
+            </a:r>
+          </a:p>
+          <a:p>
+            <a:pPr>
+              <a:spcBef>
+                <a:spcPts val="100"/>
+              </a:spcBef>
+              <a:defRPr sz="1400" b="1">
                 <a:solidFill>
                   <a:srgbClr val="0F172A"/>
                 </a:solidFill>
               </a:defRPr>
             </a:pPr>
             <a:r>
-              <a:t>Python (FastAPI)</a:t>
-            </a:r>
-            <a:br/>
-            <a:r>
-              <a:t>Async microservices, REST &amp; WebSockets, ABHA ID auth, sub-5ms indexed response times.</a:t>
+              <a:t>Python FastAPI</a:t>
+            </a:r>
+          </a:p>
+          <a:p>
+            <a:pPr>
+              <a:spcBef>
+                <a:spcPts val="600"/>
+              </a:spcBef>
+              <a:defRPr sz="1000">
+                <a:solidFill>
+                  <a:srgbClr val="334155"/>
+                </a:solidFill>
+              </a:defRPr>
+            </a:pPr>
+            <a:r>
+              <a:t>• Async Starlette pipeline (high scale)</a:t>
+            </a:r>
+          </a:p>
+          <a:p>
+            <a:pPr>
+              <a:spcBef>
+                <a:spcPts val="600"/>
+              </a:spcBef>
+              <a:defRPr sz="1000">
+                <a:solidFill>
+                  <a:srgbClr val="334155"/>
+                </a:solidFill>
+              </a:defRPr>
+            </a:pPr>
+            <a:r>
+              <a:t>• WebSockets for live community sync</a:t>
+            </a:r>
+          </a:p>
+          <a:p>
+            <a:pPr>
+              <a:spcBef>
+                <a:spcPts val="600"/>
+              </a:spcBef>
+              <a:defRPr sz="1000">
+                <a:solidFill>
+                  <a:srgbClr val="334155"/>
+                </a:solidFill>
+              </a:defRPr>
+            </a:pPr>
+            <a:r>
+              <a:t>• ABHA Gateway tokenized login</a:t>
+            </a:r>
+          </a:p>
+          <a:p>
+            <a:pPr>
+              <a:spcBef>
+                <a:spcPts val="600"/>
+              </a:spcBef>
+              <a:defRPr sz="1000">
+                <a:solidFill>
+                  <a:srgbClr val="334155"/>
+                </a:solidFill>
+              </a:defRPr>
+            </a:pPr>
+            <a:r>
+              <a:t>• Background Celery immunization crons</a:t>
+            </a:r>
+          </a:p>
+          <a:p>
+            <a:pPr>
+              <a:spcBef>
+                <a:spcPts val="1400"/>
+              </a:spcBef>
+              <a:defRPr sz="950" b="1">
+                <a:solidFill>
+                  <a:srgbClr val="4A6FA5"/>
+                </a:solidFill>
+              </a:defRPr>
+            </a:pPr>
+            <a:r>
+              <a:t>⚡ 10k+ req/sec Throughput</a:t>
             </a:r>
           </a:p>
         </p:txBody>
@@ -5028,8 +5522,8 @@
         </p:nvSpPr>
         <p:spPr>
           <a:xfrm>
-            <a:off x="5120640" y="1920240"/>
-            <a:ext cx="2011680" cy="4206240"/>
+            <a:off x="5120640" y="1737360"/>
+            <a:ext cx="2057400" cy="4663440"/>
           </a:xfrm>
           <a:prstGeom prst="roundRect">
             <a:avLst/>
@@ -5058,41 +5552,108 @@
           </a:fontRef>
         </p:style>
         <p:txBody>
-          <a:bodyPr rtlCol="0" anchor="ctr" wrap="square" tIns="182880" lIns="137160" rIns="137160"/>
+          <a:bodyPr rtlCol="0" anchor="ctr" wrap="square" tIns="137160" lIns="137160" rIns="137160" bIns="91440"/>
           <a:lstStyle/>
           <a:p>
             <a:pPr algn="ctr">
-              <a:defRPr sz="1500" b="1">
+              <a:defRPr sz="950" b="1">
                 <a:solidFill>
                   <a:srgbClr val="7C3AED"/>
                 </a:solidFill>
               </a:defRPr>
             </a:pPr>
             <a:r>
-              <a:t>Agent Orchestration</a:t>
-            </a:r>
-          </a:p>
-          <a:p>
-            <a:pPr>
-              <a:spcBef>
-                <a:spcPts val="1200"/>
-              </a:spcBef>
-              <a:defRPr sz="1100">
+              <a:t>AGENT ENGINE</a:t>
+            </a:r>
+          </a:p>
+          <a:p>
+            <a:pPr>
+              <a:spcBef>
+                <a:spcPts val="100"/>
+              </a:spcBef>
+              <a:defRPr sz="1400" b="1">
                 <a:solidFill>
                   <a:srgbClr val="0F172A"/>
                 </a:solidFill>
               </a:defRPr>
             </a:pPr>
             <a:r>
-              <a:t>LangChain / LangGraph</a:t>
-            </a:r>
-            <a:br/>
-            <a:r>
-              <a:t>vLLM-accelerated open-weights models:</a:t>
-            </a:r>
-            <a:br/>
-            <a:r>
-              <a:t>NVIDIA Nemotron / Llama 3 for sub-second milestone mapping.</a:t>
+              <a:t>vLLM + LangGraph</a:t>
+            </a:r>
+          </a:p>
+          <a:p>
+            <a:pPr>
+              <a:spcBef>
+                <a:spcPts val="600"/>
+              </a:spcBef>
+              <a:defRPr sz="1000">
+                <a:solidFill>
+                  <a:srgbClr val="334155"/>
+                </a:solidFill>
+              </a:defRPr>
+            </a:pPr>
+            <a:r>
+              <a:t>• Nemotron &amp; Llama 3 on private cloud</a:t>
+            </a:r>
+          </a:p>
+          <a:p>
+            <a:pPr>
+              <a:spcBef>
+                <a:spcPts val="600"/>
+              </a:spcBef>
+              <a:defRPr sz="1000">
+                <a:solidFill>
+                  <a:srgbClr val="334155"/>
+                </a:solidFill>
+              </a:defRPr>
+            </a:pPr>
+            <a:r>
+              <a:t>• PagedAttention memory optimization</a:t>
+            </a:r>
+          </a:p>
+          <a:p>
+            <a:pPr>
+              <a:spcBef>
+                <a:spcPts val="600"/>
+              </a:spcBef>
+              <a:defRPr sz="1000">
+                <a:solidFill>
+                  <a:srgbClr val="334155"/>
+                </a:solidFill>
+              </a:defRPr>
+            </a:pPr>
+            <a:r>
+              <a:t>• LangGraph strict non-clinical paths</a:t>
+            </a:r>
+          </a:p>
+          <a:p>
+            <a:pPr>
+              <a:spcBef>
+                <a:spcPts val="600"/>
+              </a:spcBef>
+              <a:defRPr sz="1000">
+                <a:solidFill>
+                  <a:srgbClr val="334155"/>
+                </a:solidFill>
+              </a:defRPr>
+            </a:pPr>
+            <a:r>
+              <a:t>• Zero GPU lock-in (standard Linux)</a:t>
+            </a:r>
+          </a:p>
+          <a:p>
+            <a:pPr>
+              <a:spcBef>
+                <a:spcPts val="1400"/>
+              </a:spcBef>
+              <a:defRPr sz="950" b="1">
+                <a:solidFill>
+                  <a:srgbClr val="7C3AED"/>
+                </a:solidFill>
+              </a:defRPr>
+            </a:pPr>
+            <a:r>
+              <a:t>⚡ &lt;90ms First-Token Time</a:t>
             </a:r>
           </a:p>
         </p:txBody>
@@ -5105,8 +5666,8 @@
         </p:nvSpPr>
         <p:spPr>
           <a:xfrm>
-            <a:off x="7315199" y="1920240"/>
-            <a:ext cx="2011680" cy="4206240"/>
+            <a:off x="7315199" y="1737360"/>
+            <a:ext cx="2057400" cy="4663440"/>
           </a:xfrm>
           <a:prstGeom prst="roundRect">
             <a:avLst/>
@@ -5135,41 +5696,108 @@
           </a:fontRef>
         </p:style>
         <p:txBody>
-          <a:bodyPr rtlCol="0" anchor="ctr" wrap="square" tIns="182880" lIns="137160" rIns="137160"/>
+          <a:bodyPr rtlCol="0" anchor="ctr" wrap="square" tIns="137160" lIns="137160" rIns="137160" bIns="91440"/>
           <a:lstStyle/>
           <a:p>
             <a:pPr algn="ctr">
-              <a:defRPr sz="1500" b="1">
+              <a:defRPr sz="950" b="1">
                 <a:solidFill>
                   <a:srgbClr val="0D9488"/>
                 </a:solidFill>
               </a:defRPr>
             </a:pPr>
             <a:r>
-              <a:t>Multilingual Voice</a:t>
-            </a:r>
-          </a:p>
-          <a:p>
-            <a:pPr>
-              <a:spcBef>
-                <a:spcPts val="1200"/>
-              </a:spcBef>
-              <a:defRPr sz="1100">
+              <a:t>SPEECH &amp; NLP</a:t>
+            </a:r>
+          </a:p>
+          <a:p>
+            <a:pPr>
+              <a:spcBef>
+                <a:spcPts val="100"/>
+              </a:spcBef>
+              <a:defRPr sz="1400" b="1">
                 <a:solidFill>
                   <a:srgbClr val="0F172A"/>
                 </a:solidFill>
               </a:defRPr>
             </a:pPr>
             <a:r>
-              <a:t>Open-source Whisper &amp;</a:t>
-            </a:r>
-            <a:br/>
-            <a:r>
-              <a:t>AI4Bharat IndicTrans2 / Bhashini</a:t>
-            </a:r>
-            <a:br/>
-            <a:r>
-              <a:t>Native support for 10+ Indic languages and voice notes.</a:t>
+              <a:t>Indic NLP AI</a:t>
+            </a:r>
+          </a:p>
+          <a:p>
+            <a:pPr>
+              <a:spcBef>
+                <a:spcPts val="600"/>
+              </a:spcBef>
+              <a:defRPr sz="1000">
+                <a:solidFill>
+                  <a:srgbClr val="334155"/>
+                </a:solidFill>
+              </a:defRPr>
+            </a:pPr>
+            <a:r>
+              <a:t>• Whisper STT fine-tuned on Indic accents</a:t>
+            </a:r>
+          </a:p>
+          <a:p>
+            <a:pPr>
+              <a:spcBef>
+                <a:spcPts val="600"/>
+              </a:spcBef>
+              <a:defRPr sz="1000">
+                <a:solidFill>
+                  <a:srgbClr val="334155"/>
+                </a:solidFill>
+              </a:defRPr>
+            </a:pPr>
+            <a:r>
+              <a:t>• AI4Bharat IndicTrans2 (10+ languages)</a:t>
+            </a:r>
+          </a:p>
+          <a:p>
+            <a:pPr>
+              <a:spcBef>
+                <a:spcPts val="600"/>
+              </a:spcBef>
+              <a:defRPr sz="1000">
+                <a:solidFill>
+                  <a:srgbClr val="334155"/>
+                </a:solidFill>
+              </a:defRPr>
+            </a:pPr>
+            <a:r>
+              <a:t>• Bhashini vernacular TTS voice notes</a:t>
+            </a:r>
+          </a:p>
+          <a:p>
+            <a:pPr>
+              <a:spcBef>
+                <a:spcPts val="600"/>
+              </a:spcBef>
+              <a:defRPr sz="1000">
+                <a:solidFill>
+                  <a:srgbClr val="334155"/>
+                </a:solidFill>
+              </a:defRPr>
+            </a:pPr>
+            <a:r>
+              <a:t>• 15-sec localized WhatsApp audio nudges</a:t>
+            </a:r>
+          </a:p>
+          <a:p>
+            <a:pPr>
+              <a:spcBef>
+                <a:spcPts val="1400"/>
+              </a:spcBef>
+              <a:defRPr sz="950" b="1">
+                <a:solidFill>
+                  <a:srgbClr val="0D9488"/>
+                </a:solidFill>
+              </a:defRPr>
+            </a:pPr>
+            <a:r>
+              <a:t>⚡ 10+ Indic Languages</a:t>
             </a:r>
           </a:p>
         </p:txBody>
@@ -5182,8 +5810,8 @@
         </p:nvSpPr>
         <p:spPr>
           <a:xfrm>
-            <a:off x="9509760" y="1920240"/>
-            <a:ext cx="2011680" cy="4206240"/>
+            <a:off x="9509760" y="1737360"/>
+            <a:ext cx="2057400" cy="4663440"/>
           </a:xfrm>
           <a:prstGeom prst="roundRect">
             <a:avLst/>
@@ -5212,37 +5840,108 @@
           </a:fontRef>
         </p:style>
         <p:txBody>
-          <a:bodyPr rtlCol="0" anchor="ctr" wrap="square" tIns="182880" lIns="137160" rIns="137160"/>
+          <a:bodyPr rtlCol="0" anchor="ctr" wrap="square" tIns="137160" lIns="137160" rIns="137160" bIns="91440"/>
           <a:lstStyle/>
           <a:p>
             <a:pPr algn="ctr">
-              <a:defRPr sz="1500" b="1">
+              <a:defRPr sz="950" b="1">
                 <a:solidFill>
                   <a:srgbClr val="D97706"/>
                 </a:solidFill>
               </a:defRPr>
             </a:pPr>
             <a:r>
-              <a:t>Data &amp; Audit Ledger</a:t>
-            </a:r>
-          </a:p>
-          <a:p>
-            <a:pPr>
-              <a:spcBef>
-                <a:spcPts val="1200"/>
-              </a:spcBef>
-              <a:defRPr sz="1100">
+              <a:t>DATA &amp; AUDIT</a:t>
+            </a:r>
+          </a:p>
+          <a:p>
+            <a:pPr>
+              <a:spcBef>
+                <a:spcPts val="100"/>
+              </a:spcBef>
+              <a:defRPr sz="1400" b="1">
                 <a:solidFill>
                   <a:srgbClr val="0F172A"/>
                 </a:solidFill>
               </a:defRPr>
             </a:pPr>
             <a:r>
-              <a:t>Enterprise PostgreSQL</a:t>
-            </a:r>
-            <a:br/>
-            <a:r>
-              <a:t>Encrypted row-level security, patient records, and append-only compliance audit trail.</a:t>
+              <a:t>PostgreSQL</a:t>
+            </a:r>
+          </a:p>
+          <a:p>
+            <a:pPr>
+              <a:spcBef>
+                <a:spcPts val="600"/>
+              </a:spcBef>
+              <a:defRPr sz="1000">
+                <a:solidFill>
+                  <a:srgbClr val="334155"/>
+                </a:solidFill>
+              </a:defRPr>
+            </a:pPr>
+            <a:r>
+              <a:t>• Row-Level Security (RLS) tenant lock</a:t>
+            </a:r>
+          </a:p>
+          <a:p>
+            <a:pPr>
+              <a:spcBef>
+                <a:spcPts val="600"/>
+              </a:spcBef>
+              <a:defRPr sz="1000">
+                <a:solidFill>
+                  <a:srgbClr val="334155"/>
+                </a:solidFill>
+              </a:defRPr>
+            </a:pPr>
+            <a:r>
+              <a:t>• Immutable append-only audit ledger</a:t>
+            </a:r>
+          </a:p>
+          <a:p>
+            <a:pPr>
+              <a:spcBef>
+                <a:spcPts val="600"/>
+              </a:spcBef>
+              <a:defRPr sz="1000">
+                <a:solidFill>
+                  <a:srgbClr val="334155"/>
+                </a:solidFill>
+              </a:defRPr>
+            </a:pPr>
+            <a:r>
+              <a:t>• pgvector semantic guidance search</a:t>
+            </a:r>
+          </a:p>
+          <a:p>
+            <a:pPr>
+              <a:spcBef>
+                <a:spcPts val="600"/>
+              </a:spcBef>
+              <a:defRPr sz="1000">
+                <a:solidFill>
+                  <a:srgbClr val="334155"/>
+                </a:solidFill>
+              </a:defRPr>
+            </a:pPr>
+            <a:r>
+              <a:t>• DPDP Act 2023 &amp; HIPAA compliance</a:t>
+            </a:r>
+          </a:p>
+          <a:p>
+            <a:pPr>
+              <a:spcBef>
+                <a:spcPts val="1400"/>
+              </a:spcBef>
+              <a:defRPr sz="950" b="1">
+                <a:solidFill>
+                  <a:srgbClr val="D97706"/>
+                </a:solidFill>
+              </a:defRPr>
+            </a:pPr>
+            <a:r>
+              <a:t>⚡ 100% Cryptographic Log</a:t>
             </a:r>
           </a:p>
         </p:txBody>

</xml_diff>